<commit_message>
fine tuning LLM score visuals
</commit_message>
<xml_diff>
--- a/doc/architecture.pptx
+++ b/doc/architecture.pptx
@@ -5,14 +5,15 @@
     <p:sldMasterId id="2147483648" r:id="rId1"/>
   </p:sldMasterIdLst>
   <p:notesMasterIdLst>
-    <p:notesMasterId r:id="rId4"/>
+    <p:notesMasterId r:id="rId5"/>
   </p:notesMasterIdLst>
   <p:handoutMasterIdLst>
-    <p:handoutMasterId r:id="rId5"/>
+    <p:handoutMasterId r:id="rId6"/>
   </p:handoutMasterIdLst>
   <p:sldIdLst>
-    <p:sldId id="1404" r:id="rId2"/>
-    <p:sldId id="1405" r:id="rId3"/>
+    <p:sldId id="1406" r:id="rId2"/>
+    <p:sldId id="1404" r:id="rId3"/>
+    <p:sldId id="1405" r:id="rId4"/>
   </p:sldIdLst>
   <p:sldSz cx="9906000" cy="6858000" type="A4"/>
   <p:notesSz cx="6669088" cy="9926638"/>
@@ -715,6 +716,110 @@
   <p:cSld>
     <p:spTree>
       <p:nvGrpSpPr>
+        <p:cNvPr id="1" name="">
+          <a:extLst>
+            <a:ext uri="{FF2B5EF4-FFF2-40B4-BE49-F238E27FC236}">
+              <a16:creationId xmlns:a16="http://schemas.microsoft.com/office/drawing/2014/main" id="{1A716A2E-C513-859D-A92D-E4627EE47C9D}"/>
+            </a:ext>
+          </a:extLst>
+        </p:cNvPr>
+        <p:cNvGrpSpPr/>
+        <p:nvPr/>
+      </p:nvGrpSpPr>
+      <p:grpSpPr>
+        <a:xfrm>
+          <a:off x="0" y="0"/>
+          <a:ext cx="0" cy="0"/>
+          <a:chOff x="0" y="0"/>
+          <a:chExt cx="0" cy="0"/>
+        </a:xfrm>
+      </p:grpSpPr>
+      <p:sp>
+        <p:nvSpPr>
+          <p:cNvPr id="2" name="Folienbildplatzhalter 1">
+            <a:extLst>
+              <a:ext uri="{FF2B5EF4-FFF2-40B4-BE49-F238E27FC236}">
+                <a16:creationId xmlns:a16="http://schemas.microsoft.com/office/drawing/2014/main" id="{54C4F9BC-157A-EA0B-5E07-0C72A32EDBDD}"/>
+              </a:ext>
+            </a:extLst>
+          </p:cNvPr>
+          <p:cNvSpPr>
+            <a:spLocks noGrp="1" noRot="1" noChangeAspect="1"/>
+          </p:cNvSpPr>
+          <p:nvPr>
+            <p:ph type="sldImg"/>
+          </p:nvPr>
+        </p:nvSpPr>
+        <p:spPr/>
+      </p:sp>
+      <p:sp>
+        <p:nvSpPr>
+          <p:cNvPr id="3" name="Notizenplatzhalter 2">
+            <a:extLst>
+              <a:ext uri="{FF2B5EF4-FFF2-40B4-BE49-F238E27FC236}">
+                <a16:creationId xmlns:a16="http://schemas.microsoft.com/office/drawing/2014/main" id="{AF5E9CD2-7A3E-C459-2671-8DCA9A7EFB11}"/>
+              </a:ext>
+            </a:extLst>
+          </p:cNvPr>
+          <p:cNvSpPr>
+            <a:spLocks noGrp="1"/>
+          </p:cNvSpPr>
+          <p:nvPr>
+            <p:ph type="body" idx="1"/>
+          </p:nvPr>
+        </p:nvSpPr>
+        <p:spPr/>
+        <p:txBody>
+          <a:bodyPr/>
+          <a:lstStyle/>
+          <a:p>
+            <a:endParaRPr lang="de-DE" dirty="0"/>
+          </a:p>
+        </p:txBody>
+      </p:sp>
+      <p:sp>
+        <p:nvSpPr>
+          <p:cNvPr id="4" name="Datumsplatzhalter 3">
+            <a:extLst>
+              <a:ext uri="{FF2B5EF4-FFF2-40B4-BE49-F238E27FC236}">
+                <a16:creationId xmlns:a16="http://schemas.microsoft.com/office/drawing/2014/main" id="{F21E31A4-1998-5A69-A69D-EDDA867B6601}"/>
+              </a:ext>
+            </a:extLst>
+          </p:cNvPr>
+          <p:cNvSpPr>
+            <a:spLocks noGrp="1"/>
+          </p:cNvSpPr>
+          <p:nvPr>
+            <p:ph type="dt" idx="10"/>
+          </p:nvPr>
+        </p:nvSpPr>
+        <p:spPr/>
+        <p:txBody>
+          <a:bodyPr/>
+          <a:lstStyle/>
+          <a:p>
+            <a:endParaRPr lang="de-DE"/>
+          </a:p>
+        </p:txBody>
+      </p:sp>
+    </p:spTree>
+    <p:extLst>
+      <p:ext uri="{BB962C8B-B14F-4D97-AF65-F5344CB8AC3E}">
+        <p14:creationId xmlns:p14="http://schemas.microsoft.com/office/powerpoint/2010/main" val="3808568338"/>
+      </p:ext>
+    </p:extLst>
+  </p:cSld>
+  <p:clrMapOvr>
+    <a:masterClrMapping/>
+  </p:clrMapOvr>
+</p:notes>
+</file>
+
+<file path=ppt/notesSlides/notesSlide2.xml><?xml version="1.0" encoding="utf-8"?>
+<p:notes xmlns:a="http://schemas.openxmlformats.org/drawingml/2006/main" xmlns:r="http://schemas.openxmlformats.org/officeDocument/2006/relationships" xmlns:p="http://schemas.openxmlformats.org/presentationml/2006/main">
+  <p:cSld>
+    <p:spTree>
+      <p:nvGrpSpPr>
         <p:cNvPr id="1" name=""/>
         <p:cNvGrpSpPr/>
         <p:nvPr/>
@@ -790,7 +895,7 @@
 </p:notes>
 </file>
 
-<file path=ppt/notesSlides/notesSlide2.xml><?xml version="1.0" encoding="utf-8"?>
+<file path=ppt/notesSlides/notesSlide3.xml><?xml version="1.0" encoding="utf-8"?>
 <p:notes xmlns:a="http://schemas.openxmlformats.org/drawingml/2006/main" xmlns:r="http://schemas.openxmlformats.org/officeDocument/2006/relationships" xmlns:p="http://schemas.openxmlformats.org/presentationml/2006/main">
   <p:cSld>
     <p:spTree>
@@ -5699,6 +5804,266 @@
   <p:cSld>
     <p:spTree>
       <p:nvGrpSpPr>
+        <p:cNvPr id="1" name="">
+          <a:extLst>
+            <a:ext uri="{FF2B5EF4-FFF2-40B4-BE49-F238E27FC236}">
+              <a16:creationId xmlns:a16="http://schemas.microsoft.com/office/drawing/2014/main" id="{D8C2017B-B994-87B0-A158-FF6CDF06BB2E}"/>
+            </a:ext>
+          </a:extLst>
+        </p:cNvPr>
+        <p:cNvGrpSpPr/>
+        <p:nvPr/>
+      </p:nvGrpSpPr>
+      <p:grpSpPr>
+        <a:xfrm>
+          <a:off x="0" y="0"/>
+          <a:ext cx="0" cy="0"/>
+          <a:chOff x="0" y="0"/>
+          <a:chExt cx="0" cy="0"/>
+        </a:xfrm>
+      </p:grpSpPr>
+      <p:sp>
+        <p:nvSpPr>
+          <p:cNvPr id="3" name="Foliennummernplatzhalter 2">
+            <a:extLst>
+              <a:ext uri="{FF2B5EF4-FFF2-40B4-BE49-F238E27FC236}">
+                <a16:creationId xmlns:a16="http://schemas.microsoft.com/office/drawing/2014/main" id="{4426D21A-65E2-4A69-26EC-8B97B63EBF77}"/>
+              </a:ext>
+            </a:extLst>
+          </p:cNvPr>
+          <p:cNvSpPr>
+            <a:spLocks noGrp="1"/>
+          </p:cNvSpPr>
+          <p:nvPr>
+            <p:ph type="sldNum" sz="quarter" idx="4"/>
+          </p:nvPr>
+        </p:nvSpPr>
+        <p:spPr/>
+        <p:txBody>
+          <a:bodyPr/>
+          <a:lstStyle/>
+          <a:p>
+            <a:fld id="{E1A12CDA-83D3-4EF4-BC0D-8D5887487634}" type="slidenum">
+              <a:rPr lang="de-DE" smtClean="0"/>
+              <a:pPr/>
+              <a:t>1</a:t>
+            </a:fld>
+            <a:endParaRPr lang="de-DE" dirty="0"/>
+          </a:p>
+        </p:txBody>
+      </p:sp>
+      <p:sp>
+        <p:nvSpPr>
+          <p:cNvPr id="4" name="Titel 3">
+            <a:extLst>
+              <a:ext uri="{FF2B5EF4-FFF2-40B4-BE49-F238E27FC236}">
+                <a16:creationId xmlns:a16="http://schemas.microsoft.com/office/drawing/2014/main" id="{22FA3328-5D62-192C-E188-370B805EFD56}"/>
+              </a:ext>
+            </a:extLst>
+          </p:cNvPr>
+          <p:cNvSpPr>
+            <a:spLocks noGrp="1"/>
+          </p:cNvSpPr>
+          <p:nvPr>
+            <p:ph type="title"/>
+          </p:nvPr>
+        </p:nvSpPr>
+        <p:spPr>
+          <a:xfrm>
+            <a:off x="633413" y="763588"/>
+            <a:ext cx="9272587" cy="981794"/>
+          </a:xfrm>
+        </p:spPr>
+        <p:txBody>
+          <a:bodyPr/>
+          <a:lstStyle/>
+          <a:p>
+            <a:r>
+              <a:rPr lang="en-GB" noProof="0" dirty="0"/>
+              <a:t>EZB Monitor – “hub”</a:t>
+            </a:r>
+          </a:p>
+        </p:txBody>
+      </p:sp>
+      <p:sp>
+        <p:nvSpPr>
+          <p:cNvPr id="5" name="Inhaltsplatzhalter 4">
+            <a:extLst>
+              <a:ext uri="{FF2B5EF4-FFF2-40B4-BE49-F238E27FC236}">
+                <a16:creationId xmlns:a16="http://schemas.microsoft.com/office/drawing/2014/main" id="{35887DFE-30E9-02CD-95AF-5709D5E14DEA}"/>
+              </a:ext>
+            </a:extLst>
+          </p:cNvPr>
+          <p:cNvSpPr>
+            <a:spLocks noGrp="1"/>
+          </p:cNvSpPr>
+          <p:nvPr>
+            <p:ph sz="quarter" idx="10"/>
+          </p:nvPr>
+        </p:nvSpPr>
+        <p:spPr>
+          <a:xfrm>
+            <a:off x="633600" y="1916707"/>
+            <a:ext cx="8639175" cy="4392613"/>
+          </a:xfrm>
+        </p:spPr>
+        <p:txBody>
+          <a:bodyPr/>
+          <a:lstStyle/>
+          <a:p>
+            <a:pPr marL="342900" indent="-342900">
+              <a:lnSpc>
+                <a:spcPct val="100000"/>
+              </a:lnSpc>
+              <a:buFont typeface="Arial" panose="020B0604020202020204" pitchFamily="34" charset="0"/>
+              <a:buChar char="•"/>
+            </a:pPr>
+            <a:r>
+              <a:rPr lang="en-GB" sz="2400" dirty="0"/>
+              <a:t>Website combines </a:t>
+            </a:r>
+            <a:r>
+              <a:rPr lang="en-GB" sz="2400" dirty="0" err="1"/>
+              <a:t>disparat</a:t>
+            </a:r>
+            <a:r>
+              <a:rPr lang="en-GB" sz="2400" dirty="0"/>
+              <a:t> information</a:t>
+            </a:r>
+            <a:br>
+              <a:rPr lang="en-GB" sz="2400" dirty="0"/>
+            </a:br>
+            <a:endParaRPr lang="en-GB" sz="2400" dirty="0"/>
+          </a:p>
+          <a:p>
+            <a:pPr marL="342900" indent="-342900">
+              <a:lnSpc>
+                <a:spcPct val="100000"/>
+              </a:lnSpc>
+              <a:buFont typeface="Arial" panose="020B0604020202020204" pitchFamily="34" charset="0"/>
+              <a:buChar char="•"/>
+            </a:pPr>
+            <a:r>
+              <a:rPr lang="en-GB" sz="2400" i="1" dirty="0"/>
+              <a:t>Daily </a:t>
+            </a:r>
+            <a:r>
+              <a:rPr lang="en-GB" sz="2400" dirty="0"/>
+              <a:t>digest of selected country stats </a:t>
+            </a:r>
+            <a:br>
+              <a:rPr lang="en-GB" sz="2400" dirty="0"/>
+            </a:br>
+            <a:r>
+              <a:rPr lang="en-GB" sz="2400" dirty="0"/>
+              <a:t>from </a:t>
+            </a:r>
+            <a:r>
+              <a:rPr lang="en-GB" sz="2400" dirty="0" err="1"/>
+              <a:t>Ameco</a:t>
+            </a:r>
+            <a:r>
+              <a:rPr lang="en-GB" sz="2400" dirty="0"/>
+              <a:t> and Eurostat</a:t>
+            </a:r>
+          </a:p>
+          <a:p>
+            <a:pPr marL="342900" indent="-342900">
+              <a:lnSpc>
+                <a:spcPct val="100000"/>
+              </a:lnSpc>
+              <a:buFont typeface="Arial" panose="020B0604020202020204" pitchFamily="34" charset="0"/>
+              <a:buChar char="•"/>
+            </a:pPr>
+            <a:r>
+              <a:rPr lang="en-GB" sz="2400" i="1" dirty="0"/>
+              <a:t>~Weekly </a:t>
+            </a:r>
+            <a:r>
+              <a:rPr lang="en-GB" sz="2400" dirty="0"/>
+              <a:t>digest of ECB  communications and speeches</a:t>
+            </a:r>
+          </a:p>
+          <a:p>
+            <a:pPr marL="1057275" lvl="2" indent="-342900">
+              <a:lnSpc>
+                <a:spcPct val="150000"/>
+              </a:lnSpc>
+              <a:buFont typeface="Arial" panose="020B0604020202020204" pitchFamily="34" charset="0"/>
+              <a:buChar char="•"/>
+            </a:pPr>
+            <a:r>
+              <a:rPr lang="en-GB" sz="2400" dirty="0"/>
+              <a:t>=&gt; LLM computed “scores” on ECB members and board</a:t>
+            </a:r>
+          </a:p>
+          <a:p>
+            <a:pPr marL="342900" indent="-342900">
+              <a:buFont typeface="Arial" panose="020B0604020202020204" pitchFamily="34" charset="0"/>
+              <a:buChar char="•"/>
+            </a:pPr>
+            <a:r>
+              <a:rPr lang="en-GB" sz="2400" dirty="0"/>
+              <a:t>Editorials towards board decisions</a:t>
+            </a:r>
+          </a:p>
+          <a:p>
+            <a:pPr marL="342900" indent="-342900">
+              <a:buFont typeface="Arial" panose="020B0604020202020204" pitchFamily="34" charset="0"/>
+              <a:buChar char="•"/>
+            </a:pPr>
+            <a:r>
+              <a:rPr lang="en-GB" sz="2400" dirty="0"/>
+              <a:t>Editorials around academic research </a:t>
+            </a:r>
+          </a:p>
+          <a:p>
+            <a:pPr marL="342900" indent="-342900">
+              <a:lnSpc>
+                <a:spcPct val="100000"/>
+              </a:lnSpc>
+              <a:buFont typeface="Arial" panose="020B0604020202020204" pitchFamily="34" charset="0"/>
+              <a:buChar char="•"/>
+            </a:pPr>
+            <a:endParaRPr lang="en-GB" sz="2400" noProof="0" dirty="0"/>
+          </a:p>
+          <a:p>
+            <a:pPr marL="342900" indent="-342900">
+              <a:buFont typeface="Arial" panose="020B0604020202020204" pitchFamily="34" charset="0"/>
+              <a:buChar char="•"/>
+            </a:pPr>
+            <a:endParaRPr lang="en-GB" sz="2400" dirty="0"/>
+          </a:p>
+          <a:p>
+            <a:pPr marL="342900" indent="-342900">
+              <a:buFont typeface="Arial" panose="020B0604020202020204" pitchFamily="34" charset="0"/>
+              <a:buChar char="•"/>
+            </a:pPr>
+            <a:endParaRPr lang="en-GB" sz="2400" dirty="0"/>
+          </a:p>
+          <a:p>
+            <a:endParaRPr lang="en-GB" sz="2400" noProof="0" dirty="0"/>
+          </a:p>
+        </p:txBody>
+      </p:sp>
+    </p:spTree>
+    <p:extLst>
+      <p:ext uri="{BB962C8B-B14F-4D97-AF65-F5344CB8AC3E}">
+        <p14:creationId xmlns:p14="http://schemas.microsoft.com/office/powerpoint/2010/main" val="2044547419"/>
+      </p:ext>
+    </p:extLst>
+  </p:cSld>
+  <p:clrMapOvr>
+    <a:masterClrMapping/>
+  </p:clrMapOvr>
+</p:sld>
+</file>
+
+<file path=ppt/slides/slide2.xml><?xml version="1.0" encoding="utf-8"?>
+<p:sld xmlns:a="http://schemas.openxmlformats.org/drawingml/2006/main" xmlns:r="http://schemas.openxmlformats.org/officeDocument/2006/relationships" xmlns:p="http://schemas.openxmlformats.org/presentationml/2006/main">
+  <p:cSld>
+    <p:spTree>
+      <p:nvGrpSpPr>
         <p:cNvPr id="1" name=""/>
         <p:cNvGrpSpPr/>
         <p:nvPr/>
@@ -5729,7 +6094,7 @@
             <a:fld id="{E1A12CDA-83D3-4EF4-BC0D-8D5887487634}" type="slidenum">
               <a:rPr lang="de-DE" smtClean="0"/>
               <a:pPr/>
-              <a:t>1</a:t>
+              <a:t>2</a:t>
             </a:fld>
             <a:endParaRPr lang="de-DE" dirty="0"/>
           </a:p>
@@ -5790,19 +6155,19 @@
               <a:buChar char="•"/>
             </a:pPr>
             <a:r>
-              <a:rPr lang="en-GB" noProof="0" dirty="0"/>
+              <a:rPr lang="en-GB" sz="2400" noProof="0" dirty="0"/>
               <a:t>Website/Portal to communicate research</a:t>
             </a:r>
             <a:br>
-              <a:rPr lang="en-GB" noProof="0" dirty="0"/>
+              <a:rPr lang="en-GB" sz="2400" noProof="0" dirty="0"/>
             </a:br>
             <a:r>
-              <a:rPr lang="en-GB" noProof="0" dirty="0">
+              <a:rPr lang="en-GB" sz="2400" noProof="0" dirty="0">
                 <a:hlinkClick r:id="rId3"/>
               </a:rPr>
               <a:t>https://ecb-monitor.zew.de</a:t>
             </a:r>
-            <a:endParaRPr lang="en-GB" noProof="0" dirty="0"/>
+            <a:endParaRPr lang="en-GB" sz="2400" noProof="0" dirty="0"/>
           </a:p>
           <a:p>
             <a:pPr marL="342900" indent="-342900">
@@ -5813,15 +6178,15 @@
               <a:buChar char="•"/>
             </a:pPr>
             <a:r>
-              <a:rPr lang="en-GB" dirty="0"/>
+              <a:rPr lang="en-GB" sz="2400" dirty="0"/>
               <a:t>S</a:t>
             </a:r>
             <a:r>
-              <a:rPr lang="en-GB" noProof="0" dirty="0" err="1"/>
+              <a:rPr lang="en-GB" sz="2400" noProof="0" dirty="0" err="1"/>
               <a:t>ubdomain</a:t>
             </a:r>
             <a:r>
-              <a:rPr lang="en-GB" noProof="0" dirty="0"/>
+              <a:rPr lang="en-GB" sz="2400" noProof="0" dirty="0"/>
               <a:t> of ZEW Institute, hosted at ZEW Institute</a:t>
             </a:r>
           </a:p>
@@ -5834,10 +6199,10 @@
               <a:buChar char="•"/>
             </a:pPr>
             <a:r>
-              <a:rPr lang="en-GB" dirty="0"/>
+              <a:rPr lang="en-GB" sz="2400" dirty="0"/>
               <a:t>Separate webserver, hosted at ZEW institute, at “DMZ”</a:t>
             </a:r>
-            <a:endParaRPr lang="en-GB" noProof="0" dirty="0"/>
+            <a:endParaRPr lang="en-GB" sz="2400" noProof="0" dirty="0"/>
           </a:p>
           <a:p>
             <a:pPr marL="342900" indent="-342900">
@@ -5848,7 +6213,7 @@
               <a:buChar char="•"/>
             </a:pPr>
             <a:r>
-              <a:rPr lang="en-GB" dirty="0"/>
+              <a:rPr lang="en-GB" sz="2400" dirty="0"/>
               <a:t>ZEW corporate design – cooperation with KOM</a:t>
             </a:r>
           </a:p>
@@ -5861,7 +6226,7 @@
               <a:buChar char="•"/>
             </a:pPr>
             <a:r>
-              <a:rPr lang="en-GB" dirty="0"/>
+              <a:rPr lang="en-GB" sz="2400" dirty="0"/>
               <a:t>Separate visitor statistics – no cookies</a:t>
             </a:r>
           </a:p>
@@ -5874,7 +6239,7 @@
               <a:buChar char="•"/>
             </a:pPr>
             <a:r>
-              <a:rPr lang="en-GB" dirty="0"/>
+              <a:rPr lang="en-GB" sz="2400" dirty="0"/>
               <a:t>Based on open source software</a:t>
             </a:r>
           </a:p>
@@ -5884,14 +6249,14 @@
               <a:buChar char="•"/>
             </a:pPr>
             <a:r>
-              <a:rPr lang="en-GB" sz="1800" dirty="0"/>
+              <a:rPr lang="en-GB" dirty="0"/>
               <a:t>Debian, Apache, Python, Flask, </a:t>
             </a:r>
             <a:r>
-              <a:rPr lang="en-GB" sz="1800" dirty="0" err="1"/>
+              <a:rPr lang="en-GB" dirty="0" err="1"/>
               <a:t>Echarts</a:t>
             </a:r>
-            <a:endParaRPr lang="en-GB" sz="1800" dirty="0"/>
+            <a:endParaRPr lang="en-GB" dirty="0"/>
           </a:p>
           <a:p>
             <a:pPr marL="792163" lvl="1" indent="-342900">
@@ -5899,18 +6264,9 @@
               <a:buChar char="•"/>
             </a:pPr>
             <a:r>
-              <a:rPr lang="en-GB" sz="1800"/>
-              <a:t>coding</a:t>
-            </a:r>
-            <a:r>
-              <a:rPr lang="en-GB" sz="1800" dirty="0"/>
-              <a:t>, data </a:t>
-            </a:r>
-            <a:r>
-              <a:rPr lang="en-GB" sz="1800"/>
-              <a:t>and content as git repository</a:t>
-            </a:r>
-            <a:endParaRPr lang="en-GB" sz="1800" dirty="0"/>
+              <a:rPr lang="en-GB" dirty="0"/>
+              <a:t>coding, data and content as git repository</a:t>
+            </a:r>
           </a:p>
           <a:p>
             <a:pPr marL="342900" indent="-342900">
@@ -5918,7 +6274,7 @@
               <a:buChar char="•"/>
             </a:pPr>
             <a:r>
-              <a:rPr lang="en-GB" dirty="0"/>
+              <a:rPr lang="en-GB" sz="2400" dirty="0"/>
               <a:t> </a:t>
             </a:r>
           </a:p>
@@ -5930,7 +6286,7 @@
               <a:buFont typeface="Arial" panose="020B0604020202020204" pitchFamily="34" charset="0"/>
               <a:buChar char="•"/>
             </a:pPr>
-            <a:endParaRPr lang="en-GB" dirty="0"/>
+            <a:endParaRPr lang="en-GB" sz="2400" dirty="0"/>
           </a:p>
           <a:p>
             <a:pPr marL="342900" indent="-342900">
@@ -5940,24 +6296,24 @@
               <a:buFont typeface="Arial" panose="020B0604020202020204" pitchFamily="34" charset="0"/>
               <a:buChar char="•"/>
             </a:pPr>
-            <a:endParaRPr lang="en-GB" noProof="0" dirty="0"/>
+            <a:endParaRPr lang="en-GB" sz="2400" noProof="0" dirty="0"/>
           </a:p>
           <a:p>
             <a:pPr marL="342900" indent="-342900">
               <a:buFont typeface="Arial" panose="020B0604020202020204" pitchFamily="34" charset="0"/>
               <a:buChar char="•"/>
             </a:pPr>
-            <a:endParaRPr lang="en-GB" dirty="0"/>
+            <a:endParaRPr lang="en-GB" sz="2400" dirty="0"/>
           </a:p>
           <a:p>
             <a:pPr marL="342900" indent="-342900">
               <a:buFont typeface="Arial" panose="020B0604020202020204" pitchFamily="34" charset="0"/>
               <a:buChar char="•"/>
             </a:pPr>
-            <a:endParaRPr lang="en-GB" dirty="0"/>
-          </a:p>
-          <a:p>
-            <a:endParaRPr lang="en-GB" noProof="0" dirty="0"/>
+            <a:endParaRPr lang="en-GB" sz="2400" dirty="0"/>
+          </a:p>
+          <a:p>
+            <a:endParaRPr lang="en-GB" sz="2400" noProof="0" dirty="0"/>
           </a:p>
         </p:txBody>
       </p:sp>
@@ -5974,7 +6330,7 @@
 </p:sld>
 </file>
 
-<file path=ppt/slides/slide2.xml><?xml version="1.0" encoding="utf-8"?>
+<file path=ppt/slides/slide3.xml><?xml version="1.0" encoding="utf-8"?>
 <p:sld xmlns:a="http://schemas.openxmlformats.org/drawingml/2006/main" xmlns:r="http://schemas.openxmlformats.org/officeDocument/2006/relationships" xmlns:p="http://schemas.openxmlformats.org/presentationml/2006/main">
   <p:cSld>
     <p:spTree>
@@ -6146,7 +6502,7 @@
           <a:p>
             <a:r>
               <a:rPr lang="en-GB" noProof="0" dirty="0"/>
-              <a:t>EZB Monitor - GIT</a:t>
+              <a:t>EZB Monitor – Data Flow</a:t>
             </a:r>
           </a:p>
         </p:txBody>
@@ -6447,22 +6803,15 @@
           <a:p>
             <a:pPr algn="ctr"/>
             <a:r>
-              <a:rPr lang="de-DE" dirty="0" err="1">
+              <a:rPr lang="de-DE" dirty="0">
                 <a:solidFill>
                   <a:schemeClr val="tx1"/>
                 </a:solidFill>
                 <a:latin typeface="Arial" panose="020B0604020202020204" pitchFamily="34" charset="0"/>
                 <a:cs typeface="Arial" panose="020B0604020202020204" pitchFamily="34" charset="0"/>
               </a:rPr>
-              <a:t>programming</a:t>
-            </a:r>
-            <a:endParaRPr lang="de-DE" dirty="0">
-              <a:solidFill>
-                <a:schemeClr val="tx1"/>
-              </a:solidFill>
-              <a:latin typeface="Arial" panose="020B0604020202020204" pitchFamily="34" charset="0"/>
-              <a:cs typeface="Arial" panose="020B0604020202020204" pitchFamily="34" charset="0"/>
-            </a:endParaRPr>
+              <a:t>Editorials</a:t>
+            </a:r>
           </a:p>
         </p:txBody>
       </p:sp>
@@ -6515,17 +6864,66 @@
           <a:p>
             <a:pPr algn="ctr"/>
             <a:r>
-              <a:rPr lang="de-DE" dirty="0" err="1">
+              <a:rPr lang="de-DE" sz="1400" dirty="0">
                 <a:solidFill>
                   <a:schemeClr val="tx1"/>
                 </a:solidFill>
                 <a:latin typeface="Arial" panose="020B0604020202020204" pitchFamily="34" charset="0"/>
                 <a:cs typeface="Arial" panose="020B0604020202020204" pitchFamily="34" charset="0"/>
               </a:rPr>
-              <a:t>research</a:t>
-            </a:r>
-            <a:r>
-              <a:rPr lang="de-DE" dirty="0">
+              <a:t>LLM </a:t>
+            </a:r>
+            <a:r>
+              <a:rPr lang="de-DE" sz="1400" dirty="0" err="1">
+                <a:solidFill>
+                  <a:schemeClr val="tx1"/>
+                </a:solidFill>
+                <a:latin typeface="Arial" panose="020B0604020202020204" pitchFamily="34" charset="0"/>
+                <a:cs typeface="Arial" panose="020B0604020202020204" pitchFamily="34" charset="0"/>
+              </a:rPr>
+              <a:t>compute</a:t>
+            </a:r>
+            <a:br>
+              <a:rPr lang="de-DE" sz="1400" dirty="0">
+                <a:solidFill>
+                  <a:schemeClr val="tx1"/>
+                </a:solidFill>
+                <a:latin typeface="Arial" panose="020B0604020202020204" pitchFamily="34" charset="0"/>
+                <a:cs typeface="Arial" panose="020B0604020202020204" pitchFamily="34" charset="0"/>
+              </a:rPr>
+            </a:br>
+            <a:r>
+              <a:rPr lang="de-DE" sz="1100" dirty="0" err="1">
+                <a:solidFill>
+                  <a:schemeClr val="tx1"/>
+                </a:solidFill>
+                <a:latin typeface="Arial" panose="020B0604020202020204" pitchFamily="34" charset="0"/>
+                <a:cs typeface="Arial" panose="020B0604020202020204" pitchFamily="34" charset="0"/>
+              </a:rPr>
+              <a:t>automated</a:t>
+            </a:r>
+            <a:r>
+              <a:rPr lang="de-DE" sz="1100" dirty="0">
+                <a:solidFill>
+                  <a:schemeClr val="tx1"/>
+                </a:solidFill>
+                <a:latin typeface="Arial" panose="020B0604020202020204" pitchFamily="34" charset="0"/>
+                <a:cs typeface="Arial" panose="020B0604020202020204" pitchFamily="34" charset="0"/>
+              </a:rPr>
+              <a:t>, </a:t>
+            </a:r>
+            <a:r>
+              <a:rPr lang="de-DE" sz="1100" dirty="0" err="1">
+                <a:solidFill>
+                  <a:schemeClr val="tx1"/>
+                </a:solidFill>
+                <a:latin typeface="Arial" panose="020B0604020202020204" pitchFamily="34" charset="0"/>
+                <a:cs typeface="Arial" panose="020B0604020202020204" pitchFamily="34" charset="0"/>
+              </a:rPr>
+              <a:t>moved</a:t>
+            </a:r>
+            <a:r>
+              <a:rPr lang="de-DE" sz="1100" dirty="0">
                 <a:solidFill>
                   <a:schemeClr val="tx1"/>
                 </a:solidFill>
@@ -6535,16 +6933,26 @@
               <a:t> </a:t>
             </a:r>
             <a:r>
-              <a:rPr lang="de-DE" dirty="0" err="1">
+              <a:rPr lang="de-DE" sz="1100" dirty="0" err="1">
                 <a:solidFill>
                   <a:schemeClr val="tx1"/>
                 </a:solidFill>
                 <a:latin typeface="Arial" panose="020B0604020202020204" pitchFamily="34" charset="0"/>
                 <a:cs typeface="Arial" panose="020B0604020202020204" pitchFamily="34" charset="0"/>
               </a:rPr>
-              <a:t>data</a:t>
-            </a:r>
-            <a:endParaRPr lang="de-DE" dirty="0">
+              <a:t>to</a:t>
+            </a:r>
+            <a:r>
+              <a:rPr lang="de-DE" sz="1100" dirty="0">
+                <a:solidFill>
+                  <a:schemeClr val="tx1"/>
+                </a:solidFill>
+                <a:latin typeface="Arial" panose="020B0604020202020204" pitchFamily="34" charset="0"/>
+                <a:cs typeface="Arial" panose="020B0604020202020204" pitchFamily="34" charset="0"/>
+              </a:rPr>
+              <a:t> Server</a:t>
+            </a:r>
+            <a:endParaRPr lang="de-DE" sz="1400" dirty="0">
               <a:solidFill>
                 <a:schemeClr val="tx1"/>
               </a:solidFill>
@@ -6603,36 +7011,45 @@
           <a:p>
             <a:pPr algn="ctr"/>
             <a:r>
-              <a:rPr lang="de-DE" dirty="0" err="1">
+              <a:rPr lang="de-DE" sz="1400" dirty="0" err="1">
                 <a:solidFill>
                   <a:schemeClr val="tx1"/>
                 </a:solidFill>
                 <a:latin typeface="Arial" panose="020B0604020202020204" pitchFamily="34" charset="0"/>
                 <a:cs typeface="Arial" panose="020B0604020202020204" pitchFamily="34" charset="0"/>
               </a:rPr>
-              <a:t>blog</a:t>
-            </a:r>
-            <a:r>
-              <a:rPr lang="de-DE" dirty="0">
+              <a:t>programming</a:t>
+            </a:r>
+            <a:br>
+              <a:rPr lang="de-DE" sz="1400" dirty="0">
                 <a:solidFill>
                   <a:schemeClr val="tx1"/>
                 </a:solidFill>
                 <a:latin typeface="Arial" panose="020B0604020202020204" pitchFamily="34" charset="0"/>
                 <a:cs typeface="Arial" panose="020B0604020202020204" pitchFamily="34" charset="0"/>
               </a:rPr>
-              <a:t> </a:t>
-            </a:r>
-            <a:r>
-              <a:rPr lang="de-DE" dirty="0" err="1">
+            </a:br>
+            <a:r>
+              <a:rPr lang="de-DE" sz="1050" dirty="0" err="1">
                 <a:solidFill>
                   <a:schemeClr val="tx1"/>
                 </a:solidFill>
                 <a:latin typeface="Arial" panose="020B0604020202020204" pitchFamily="34" charset="0"/>
                 <a:cs typeface="Arial" panose="020B0604020202020204" pitchFamily="34" charset="0"/>
               </a:rPr>
-              <a:t>content</a:t>
-            </a:r>
-            <a:endParaRPr lang="de-DE" dirty="0">
+              <a:t>phased</a:t>
+            </a:r>
+            <a:r>
+              <a:rPr lang="de-DE" sz="1050" dirty="0">
+                <a:solidFill>
+                  <a:schemeClr val="tx1"/>
+                </a:solidFill>
+                <a:latin typeface="Arial" panose="020B0604020202020204" pitchFamily="34" charset="0"/>
+                <a:cs typeface="Arial" panose="020B0604020202020204" pitchFamily="34" charset="0"/>
+              </a:rPr>
+              <a:t> out</a:t>
+            </a:r>
+            <a:endParaRPr lang="de-DE" sz="1400" dirty="0">
               <a:solidFill>
                 <a:schemeClr val="tx1"/>
               </a:solidFill>
@@ -6844,7 +7261,7 @@
         </p:nvSpPr>
         <p:spPr>
           <a:xfrm>
-            <a:off x="7373946" y="5236764"/>
+            <a:off x="7373946" y="5599819"/>
             <a:ext cx="2016224" cy="360040"/>
           </a:xfrm>
           <a:prstGeom prst="roundRect">
@@ -6912,7 +7329,7 @@
         </p:nvSpPr>
         <p:spPr>
           <a:xfrm>
-            <a:off x="7373946" y="5730241"/>
+            <a:off x="7373946" y="6093296"/>
             <a:ext cx="2016224" cy="360040"/>
           </a:xfrm>
           <a:prstGeom prst="roundRect">
@@ -6980,8 +7397,8 @@
         </p:nvSpPr>
         <p:spPr>
           <a:xfrm>
-            <a:off x="7354474" y="4732708"/>
-            <a:ext cx="2016224" cy="360040"/>
+            <a:off x="7354474" y="4732707"/>
+            <a:ext cx="2016224" cy="687091"/>
           </a:xfrm>
           <a:prstGeom prst="roundRect">
             <a:avLst/>
@@ -7034,6 +7451,35 @@
               </a:rPr>
               <a:t>speeches</a:t>
             </a:r>
+            <a:br>
+              <a:rPr lang="de-DE" dirty="0">
+                <a:solidFill>
+                  <a:schemeClr val="tx1"/>
+                </a:solidFill>
+                <a:latin typeface="Arial" panose="020B0604020202020204" pitchFamily="34" charset="0"/>
+                <a:cs typeface="Arial" panose="020B0604020202020204" pitchFamily="34" charset="0"/>
+              </a:rPr>
+            </a:br>
+            <a:r>
+              <a:rPr lang="de-DE" sz="1400" dirty="0">
+                <a:solidFill>
+                  <a:schemeClr val="tx1"/>
+                </a:solidFill>
+                <a:latin typeface="Arial" panose="020B0604020202020204" pitchFamily="34" charset="0"/>
+                <a:cs typeface="Arial" panose="020B0604020202020204" pitchFamily="34" charset="0"/>
+              </a:rPr>
+              <a:t>LLM </a:t>
+            </a:r>
+            <a:r>
+              <a:rPr lang="de-DE" sz="1400" dirty="0" err="1">
+                <a:solidFill>
+                  <a:schemeClr val="tx1"/>
+                </a:solidFill>
+                <a:latin typeface="Arial" panose="020B0604020202020204" pitchFamily="34" charset="0"/>
+                <a:cs typeface="Arial" panose="020B0604020202020204" pitchFamily="34" charset="0"/>
+              </a:rPr>
+              <a:t>compute</a:t>
+            </a:r>
             <a:endParaRPr lang="de-DE" dirty="0">
               <a:solidFill>
                 <a:schemeClr val="tx1"/>
@@ -7063,7 +7509,7 @@
         <p:spPr>
           <a:xfrm>
             <a:off x="6969224" y="3645024"/>
-            <a:ext cx="385250" cy="1267704"/>
+            <a:ext cx="385250" cy="1431229"/>
           </a:xfrm>
           <a:prstGeom prst="bentConnector3">
             <a:avLst>
@@ -7110,7 +7556,7 @@
         <p:spPr>
           <a:xfrm>
             <a:off x="6969224" y="3645024"/>
-            <a:ext cx="404722" cy="1771760"/>
+            <a:ext cx="404722" cy="2134815"/>
           </a:xfrm>
           <a:prstGeom prst="bentConnector3">
             <a:avLst>
@@ -7157,7 +7603,7 @@
         <p:spPr>
           <a:xfrm>
             <a:off x="6969224" y="3645024"/>
-            <a:ext cx="404722" cy="2265237"/>
+            <a:ext cx="404722" cy="2628292"/>
           </a:xfrm>
           <a:prstGeom prst="bentConnector3">
             <a:avLst>
@@ -7272,8 +7718,8 @@
         </p:nvSpPr>
         <p:spPr>
           <a:xfrm>
-            <a:off x="4953000" y="2492896"/>
-            <a:ext cx="477695" cy="430887"/>
+            <a:off x="4964348" y="2494057"/>
+            <a:ext cx="407163" cy="369332"/>
           </a:xfrm>
           <a:prstGeom prst="rect">
             <a:avLst/>
@@ -7287,26 +7733,26 @@
           <a:lstStyle/>
           <a:p>
             <a:r>
-              <a:rPr lang="de-DE" sz="1400" dirty="0" err="1">
+              <a:rPr lang="de-DE" sz="1200" dirty="0" err="1">
+                <a:latin typeface="Arial" panose="020B0604020202020204" pitchFamily="34" charset="0"/>
+                <a:cs typeface="Arial" panose="020B0604020202020204" pitchFamily="34" charset="0"/>
+              </a:rPr>
+              <a:t>data</a:t>
+            </a:r>
+            <a:br>
+              <a:rPr lang="de-DE" sz="1200" dirty="0">
+                <a:latin typeface="Arial" panose="020B0604020202020204" pitchFamily="34" charset="0"/>
+                <a:cs typeface="Arial" panose="020B0604020202020204" pitchFamily="34" charset="0"/>
+              </a:rPr>
+            </a:br>
+            <a:r>
+              <a:rPr lang="de-DE" sz="1200" dirty="0" err="1">
                 <a:latin typeface="Arial" panose="020B0604020202020204" pitchFamily="34" charset="0"/>
                 <a:cs typeface="Arial" panose="020B0604020202020204" pitchFamily="34" charset="0"/>
               </a:rPr>
               <a:t>pulled</a:t>
             </a:r>
-            <a:endParaRPr lang="de-DE" sz="1400" dirty="0">
-              <a:latin typeface="Arial" panose="020B0604020202020204" pitchFamily="34" charset="0"/>
-              <a:cs typeface="Arial" panose="020B0604020202020204" pitchFamily="34" charset="0"/>
-            </a:endParaRPr>
-          </a:p>
-          <a:p>
-            <a:r>
-              <a:rPr lang="de-DE" sz="1400" dirty="0" err="1">
-                <a:latin typeface="Arial" panose="020B0604020202020204" pitchFamily="34" charset="0"/>
-                <a:cs typeface="Arial" panose="020B0604020202020204" pitchFamily="34" charset="0"/>
-              </a:rPr>
-              <a:t>data</a:t>
-            </a:r>
-            <a:endParaRPr lang="de-DE" sz="1400" dirty="0">
+            <a:endParaRPr lang="de-DE" sz="1200" dirty="0">
               <a:latin typeface="Arial" panose="020B0604020202020204" pitchFamily="34" charset="0"/>
               <a:cs typeface="Arial" panose="020B0604020202020204" pitchFamily="34" charset="0"/>
             </a:endParaRPr>
@@ -7327,8 +7773,8 @@
         </p:nvSpPr>
         <p:spPr>
           <a:xfrm>
-            <a:off x="4880992" y="3645024"/>
-            <a:ext cx="586699" cy="430887"/>
+            <a:off x="4953713" y="3707740"/>
+            <a:ext cx="503343" cy="369332"/>
           </a:xfrm>
           <a:prstGeom prst="rect">
             <a:avLst/>
@@ -7342,26 +7788,26 @@
           <a:lstStyle/>
           <a:p>
             <a:r>
-              <a:rPr lang="de-DE" sz="1400" dirty="0" err="1">
+              <a:rPr lang="de-DE" sz="1200" dirty="0" err="1">
+                <a:latin typeface="Arial" panose="020B0604020202020204" pitchFamily="34" charset="0"/>
+                <a:cs typeface="Arial" panose="020B0604020202020204" pitchFamily="34" charset="0"/>
+              </a:rPr>
+              <a:t>content</a:t>
+            </a:r>
+            <a:br>
+              <a:rPr lang="de-DE" sz="1200" dirty="0">
+                <a:latin typeface="Arial" panose="020B0604020202020204" pitchFamily="34" charset="0"/>
+                <a:cs typeface="Arial" panose="020B0604020202020204" pitchFamily="34" charset="0"/>
+              </a:rPr>
+            </a:br>
+            <a:r>
+              <a:rPr lang="de-DE" sz="1200" dirty="0" err="1">
                 <a:latin typeface="Arial" panose="020B0604020202020204" pitchFamily="34" charset="0"/>
                 <a:cs typeface="Arial" panose="020B0604020202020204" pitchFamily="34" charset="0"/>
               </a:rPr>
               <a:t>pushed</a:t>
             </a:r>
-            <a:endParaRPr lang="de-DE" sz="1400" dirty="0">
-              <a:latin typeface="Arial" panose="020B0604020202020204" pitchFamily="34" charset="0"/>
-              <a:cs typeface="Arial" panose="020B0604020202020204" pitchFamily="34" charset="0"/>
-            </a:endParaRPr>
-          </a:p>
-          <a:p>
-            <a:r>
-              <a:rPr lang="de-DE" sz="1400" dirty="0" err="1">
-                <a:latin typeface="Arial" panose="020B0604020202020204" pitchFamily="34" charset="0"/>
-                <a:cs typeface="Arial" panose="020B0604020202020204" pitchFamily="34" charset="0"/>
-              </a:rPr>
-              <a:t>content</a:t>
-            </a:r>
-            <a:endParaRPr lang="de-DE" sz="1400" dirty="0">
+            <a:endParaRPr lang="de-DE" sz="1200" dirty="0">
               <a:latin typeface="Arial" panose="020B0604020202020204" pitchFamily="34" charset="0"/>
               <a:cs typeface="Arial" panose="020B0604020202020204" pitchFamily="34" charset="0"/>
             </a:endParaRPr>
@@ -7382,8 +7828,8 @@
         </p:nvSpPr>
         <p:spPr>
           <a:xfrm>
-            <a:off x="3656856" y="3573016"/>
-            <a:ext cx="924933" cy="215444"/>
+            <a:off x="3584848" y="3573016"/>
+            <a:ext cx="1440160" cy="1107996"/>
           </a:xfrm>
           <a:prstGeom prst="rect">
             <a:avLst/>
@@ -7391,28 +7837,403 @@
           <a:noFill/>
         </p:spPr>
         <p:txBody>
-          <a:bodyPr wrap="none" lIns="0" tIns="0" rIns="0" bIns="0" rtlCol="0">
+          <a:bodyPr wrap="square" lIns="0" tIns="0" rIns="0" bIns="0" rtlCol="0">
             <a:spAutoFit/>
           </a:bodyPr>
           <a:lstStyle/>
           <a:p>
-            <a:r>
-              <a:rPr lang="de-DE" sz="1400" dirty="0" err="1">
+            <a:pPr marL="171450" indent="-171450">
+              <a:buFont typeface="Arial" panose="020B0604020202020204" pitchFamily="34" charset="0"/>
+              <a:buChar char="•"/>
+            </a:pPr>
+            <a:r>
+              <a:rPr lang="de-DE" sz="1200" dirty="0">
                 <a:latin typeface="Arial" panose="020B0604020202020204" pitchFamily="34" charset="0"/>
                 <a:cs typeface="Arial" panose="020B0604020202020204" pitchFamily="34" charset="0"/>
               </a:rPr>
-              <a:t>auto</a:t>
-            </a:r>
-            <a:r>
-              <a:rPr lang="de-DE" sz="1400" dirty="0">
+              <a:t>All </a:t>
+            </a:r>
+            <a:r>
+              <a:rPr lang="de-DE" sz="1200" dirty="0" err="1">
                 <a:latin typeface="Arial" panose="020B0604020202020204" pitchFamily="34" charset="0"/>
                 <a:cs typeface="Arial" panose="020B0604020202020204" pitchFamily="34" charset="0"/>
               </a:rPr>
-              <a:t> deploy</a:t>
-            </a:r>
-          </a:p>
-        </p:txBody>
-      </p:sp>
+              <a:t>data</a:t>
+            </a:r>
+            <a:r>
+              <a:rPr lang="de-DE" sz="1200" dirty="0">
+                <a:latin typeface="Arial" panose="020B0604020202020204" pitchFamily="34" charset="0"/>
+                <a:cs typeface="Arial" panose="020B0604020202020204" pitchFamily="34" charset="0"/>
+              </a:rPr>
+              <a:t> </a:t>
+            </a:r>
+            <a:r>
+              <a:rPr lang="de-DE" sz="1200" dirty="0" err="1">
+                <a:latin typeface="Arial" panose="020B0604020202020204" pitchFamily="34" charset="0"/>
+                <a:cs typeface="Arial" panose="020B0604020202020204" pitchFamily="34" charset="0"/>
+              </a:rPr>
+              <a:t>with</a:t>
+            </a:r>
+            <a:r>
+              <a:rPr lang="de-DE" sz="1200" dirty="0">
+                <a:latin typeface="Arial" panose="020B0604020202020204" pitchFamily="34" charset="0"/>
+                <a:cs typeface="Arial" panose="020B0604020202020204" pitchFamily="34" charset="0"/>
+              </a:rPr>
+              <a:t> </a:t>
+            </a:r>
+            <a:br>
+              <a:rPr lang="de-DE" sz="1200" dirty="0">
+                <a:latin typeface="Arial" panose="020B0604020202020204" pitchFamily="34" charset="0"/>
+                <a:cs typeface="Arial" panose="020B0604020202020204" pitchFamily="34" charset="0"/>
+              </a:rPr>
+            </a:br>
+            <a:r>
+              <a:rPr lang="de-DE" sz="1200" dirty="0" err="1">
+                <a:latin typeface="Arial" panose="020B0604020202020204" pitchFamily="34" charset="0"/>
+                <a:cs typeface="Arial" panose="020B0604020202020204" pitchFamily="34" charset="0"/>
+              </a:rPr>
+              <a:t>version</a:t>
+            </a:r>
+            <a:r>
+              <a:rPr lang="de-DE" sz="1200" dirty="0">
+                <a:latin typeface="Arial" panose="020B0604020202020204" pitchFamily="34" charset="0"/>
+                <a:cs typeface="Arial" panose="020B0604020202020204" pitchFamily="34" charset="0"/>
+              </a:rPr>
+              <a:t> </a:t>
+            </a:r>
+            <a:r>
+              <a:rPr lang="de-DE" sz="1200" dirty="0" err="1">
+                <a:latin typeface="Arial" panose="020B0604020202020204" pitchFamily="34" charset="0"/>
+                <a:cs typeface="Arial" panose="020B0604020202020204" pitchFamily="34" charset="0"/>
+              </a:rPr>
+              <a:t>history</a:t>
+            </a:r>
+            <a:endParaRPr lang="de-DE" sz="1200" dirty="0">
+              <a:latin typeface="Arial" panose="020B0604020202020204" pitchFamily="34" charset="0"/>
+              <a:cs typeface="Arial" panose="020B0604020202020204" pitchFamily="34" charset="0"/>
+            </a:endParaRPr>
+          </a:p>
+          <a:p>
+            <a:pPr marL="171450" indent="-171450">
+              <a:buFont typeface="Arial" panose="020B0604020202020204" pitchFamily="34" charset="0"/>
+              <a:buChar char="•"/>
+            </a:pPr>
+            <a:r>
+              <a:rPr lang="de-DE" sz="1200" dirty="0">
+                <a:latin typeface="Arial" panose="020B0604020202020204" pitchFamily="34" charset="0"/>
+                <a:cs typeface="Arial" panose="020B0604020202020204" pitchFamily="34" charset="0"/>
+              </a:rPr>
+              <a:t>Auto deploy</a:t>
+            </a:r>
+          </a:p>
+          <a:p>
+            <a:pPr marL="171450" indent="-171450">
+              <a:buFont typeface="Arial" panose="020B0604020202020204" pitchFamily="34" charset="0"/>
+              <a:buChar char="•"/>
+            </a:pPr>
+            <a:r>
+              <a:rPr lang="de-DE" sz="1200" dirty="0">
+                <a:latin typeface="Arial" panose="020B0604020202020204" pitchFamily="34" charset="0"/>
+                <a:cs typeface="Arial" panose="020B0604020202020204" pitchFamily="34" charset="0"/>
+              </a:rPr>
+              <a:t>Backup</a:t>
+            </a:r>
+          </a:p>
+          <a:p>
+            <a:pPr marL="171450" indent="-171450">
+              <a:buFont typeface="Arial" panose="020B0604020202020204" pitchFamily="34" charset="0"/>
+              <a:buChar char="•"/>
+            </a:pPr>
+            <a:r>
+              <a:rPr lang="de-DE" sz="1200" dirty="0" err="1">
+                <a:latin typeface="Arial" panose="020B0604020202020204" pitchFamily="34" charset="0"/>
+                <a:cs typeface="Arial" panose="020B0604020202020204" pitchFamily="34" charset="0"/>
+              </a:rPr>
+              <a:t>Vulnerability</a:t>
+            </a:r>
+            <a:r>
+              <a:rPr lang="de-DE" sz="1200" dirty="0">
+                <a:latin typeface="Arial" panose="020B0604020202020204" pitchFamily="34" charset="0"/>
+                <a:cs typeface="Arial" panose="020B0604020202020204" pitchFamily="34" charset="0"/>
+              </a:rPr>
+              <a:t> </a:t>
+            </a:r>
+            <a:br>
+              <a:rPr lang="de-DE" sz="1200" dirty="0">
+                <a:latin typeface="Arial" panose="020B0604020202020204" pitchFamily="34" charset="0"/>
+                <a:cs typeface="Arial" panose="020B0604020202020204" pitchFamily="34" charset="0"/>
+              </a:rPr>
+            </a:br>
+            <a:r>
+              <a:rPr lang="de-DE" sz="1200" dirty="0" err="1">
+                <a:latin typeface="Arial" panose="020B0604020202020204" pitchFamily="34" charset="0"/>
+                <a:cs typeface="Arial" panose="020B0604020202020204" pitchFamily="34" charset="0"/>
+              </a:rPr>
+              <a:t>scan</a:t>
+            </a:r>
+            <a:endParaRPr lang="de-DE" sz="1200" dirty="0">
+              <a:latin typeface="Arial" panose="020B0604020202020204" pitchFamily="34" charset="0"/>
+              <a:cs typeface="Arial" panose="020B0604020202020204" pitchFamily="34" charset="0"/>
+            </a:endParaRPr>
+          </a:p>
+        </p:txBody>
+      </p:sp>
+      <p:sp>
+        <p:nvSpPr>
+          <p:cNvPr id="3" name="Flussdiagramm: Anzeige 2">
+            <a:extLst>
+              <a:ext uri="{FF2B5EF4-FFF2-40B4-BE49-F238E27FC236}">
+                <a16:creationId xmlns:a16="http://schemas.microsoft.com/office/drawing/2014/main" id="{40211A0D-9DCE-18CE-89BA-EBE688513A02}"/>
+              </a:ext>
+            </a:extLst>
+          </p:cNvPr>
+          <p:cNvSpPr/>
+          <p:nvPr/>
+        </p:nvSpPr>
+        <p:spPr>
+          <a:xfrm>
+            <a:off x="6969224" y="1268070"/>
+            <a:ext cx="936104" cy="684075"/>
+          </a:xfrm>
+          <a:prstGeom prst="flowChartDisplay">
+            <a:avLst/>
+          </a:prstGeom>
+          <a:noFill/>
+          <a:ln w="15875">
+            <a:solidFill>
+              <a:schemeClr val="tx1">
+                <a:lumMod val="65000"/>
+                <a:lumOff val="35000"/>
+              </a:schemeClr>
+            </a:solidFill>
+          </a:ln>
+        </p:spPr>
+        <p:style>
+          <a:lnRef idx="2">
+            <a:schemeClr val="accent1">
+              <a:shade val="50000"/>
+            </a:schemeClr>
+          </a:lnRef>
+          <a:fillRef idx="1">
+            <a:schemeClr val="accent1"/>
+          </a:fillRef>
+          <a:effectRef idx="0">
+            <a:schemeClr val="accent1"/>
+          </a:effectRef>
+          <a:fontRef idx="minor">
+            <a:schemeClr val="lt1"/>
+          </a:fontRef>
+        </p:style>
+        <p:txBody>
+          <a:bodyPr lIns="0" tIns="36000" rIns="0" bIns="36000" rtlCol="0" anchor="ctr"/>
+          <a:lstStyle/>
+          <a:p>
+            <a:pPr algn="ctr"/>
+            <a:r>
+              <a:rPr lang="de-DE" sz="1200" dirty="0" err="1">
+                <a:solidFill>
+                  <a:schemeClr val="tx1"/>
+                </a:solidFill>
+                <a:latin typeface="Arial" panose="020B0604020202020204" pitchFamily="34" charset="0"/>
+                <a:cs typeface="Arial" panose="020B0604020202020204" pitchFamily="34" charset="0"/>
+              </a:rPr>
+              <a:t>Statistics</a:t>
+            </a:r>
+            <a:endParaRPr lang="de-DE" sz="1200" dirty="0">
+              <a:solidFill>
+                <a:schemeClr val="tx1"/>
+              </a:solidFill>
+              <a:latin typeface="Arial" panose="020B0604020202020204" pitchFamily="34" charset="0"/>
+              <a:cs typeface="Arial" panose="020B0604020202020204" pitchFamily="34" charset="0"/>
+            </a:endParaRPr>
+          </a:p>
+        </p:txBody>
+      </p:sp>
+      <p:sp>
+        <p:nvSpPr>
+          <p:cNvPr id="10" name="Flussdiagramm: Anzeige 9">
+            <a:extLst>
+              <a:ext uri="{FF2B5EF4-FFF2-40B4-BE49-F238E27FC236}">
+                <a16:creationId xmlns:a16="http://schemas.microsoft.com/office/drawing/2014/main" id="{B5231C3A-9128-BD35-670D-DAB96A5AF82C}"/>
+              </a:ext>
+            </a:extLst>
+          </p:cNvPr>
+          <p:cNvSpPr/>
+          <p:nvPr/>
+        </p:nvSpPr>
+        <p:spPr>
+          <a:xfrm>
+            <a:off x="8013005" y="1772816"/>
+            <a:ext cx="936104" cy="684075"/>
+          </a:xfrm>
+          <a:prstGeom prst="flowChartDisplay">
+            <a:avLst/>
+          </a:prstGeom>
+          <a:noFill/>
+          <a:ln w="15875">
+            <a:solidFill>
+              <a:schemeClr val="tx1">
+                <a:lumMod val="65000"/>
+                <a:lumOff val="35000"/>
+              </a:schemeClr>
+            </a:solidFill>
+          </a:ln>
+        </p:spPr>
+        <p:style>
+          <a:lnRef idx="2">
+            <a:schemeClr val="accent1">
+              <a:shade val="50000"/>
+            </a:schemeClr>
+          </a:lnRef>
+          <a:fillRef idx="1">
+            <a:schemeClr val="accent1"/>
+          </a:fillRef>
+          <a:effectRef idx="0">
+            <a:schemeClr val="accent1"/>
+          </a:effectRef>
+          <a:fontRef idx="minor">
+            <a:schemeClr val="lt1"/>
+          </a:fontRef>
+        </p:style>
+        <p:txBody>
+          <a:bodyPr lIns="0" tIns="36000" rIns="0" bIns="36000" rtlCol="0" anchor="ctr"/>
+          <a:lstStyle/>
+          <a:p>
+            <a:pPr algn="ctr"/>
+            <a:r>
+              <a:rPr lang="de-DE" sz="1200" dirty="0">
+                <a:solidFill>
+                  <a:schemeClr val="tx1"/>
+                </a:solidFill>
+                <a:latin typeface="Arial" panose="020B0604020202020204" pitchFamily="34" charset="0"/>
+                <a:cs typeface="Arial" panose="020B0604020202020204" pitchFamily="34" charset="0"/>
+              </a:rPr>
+              <a:t>Monitor</a:t>
+            </a:r>
+            <a:br>
+              <a:rPr lang="de-DE" sz="1200" dirty="0">
+                <a:solidFill>
+                  <a:schemeClr val="tx1"/>
+                </a:solidFill>
+                <a:latin typeface="Arial" panose="020B0604020202020204" pitchFamily="34" charset="0"/>
+                <a:cs typeface="Arial" panose="020B0604020202020204" pitchFamily="34" charset="0"/>
+              </a:rPr>
+            </a:br>
+            <a:r>
+              <a:rPr lang="de-DE" sz="1200" dirty="0">
+                <a:solidFill>
+                  <a:schemeClr val="tx1"/>
+                </a:solidFill>
+                <a:latin typeface="Arial" panose="020B0604020202020204" pitchFamily="34" charset="0"/>
+                <a:cs typeface="Arial" panose="020B0604020202020204" pitchFamily="34" charset="0"/>
+              </a:rPr>
+              <a:t>&amp; Alarm</a:t>
+            </a:r>
+          </a:p>
+        </p:txBody>
+      </p:sp>
+      <p:cxnSp>
+        <p:nvCxnSpPr>
+          <p:cNvPr id="12" name="Verbinder: gewinkelt 11">
+            <a:extLst>
+              <a:ext uri="{FF2B5EF4-FFF2-40B4-BE49-F238E27FC236}">
+                <a16:creationId xmlns:a16="http://schemas.microsoft.com/office/drawing/2014/main" id="{47B39FB2-72D4-932A-8352-B11B2B70FB65}"/>
+              </a:ext>
+            </a:extLst>
+          </p:cNvPr>
+          <p:cNvCxnSpPr>
+            <a:cxnSpLocks/>
+            <a:stCxn id="3" idx="1"/>
+            <a:endCxn id="6" idx="0"/>
+          </p:cNvCxnSpPr>
+          <p:nvPr/>
+        </p:nvCxnSpPr>
+        <p:spPr>
+          <a:xfrm rot="10800000" flipV="1">
+            <a:off x="6285148" y="1610108"/>
+            <a:ext cx="684076" cy="1170820"/>
+          </a:xfrm>
+          <a:prstGeom prst="bentConnector2">
+            <a:avLst/>
+          </a:prstGeom>
+          <a:ln w="15875">
+            <a:solidFill>
+              <a:schemeClr val="tx1">
+                <a:lumMod val="65000"/>
+                <a:lumOff val="35000"/>
+              </a:schemeClr>
+            </a:solidFill>
+            <a:headEnd type="triangle"/>
+            <a:tailEnd type="none"/>
+          </a:ln>
+          <a:effectLst/>
+        </p:spPr>
+        <p:style>
+          <a:lnRef idx="2">
+            <a:schemeClr val="accent1"/>
+          </a:lnRef>
+          <a:fillRef idx="0">
+            <a:schemeClr val="accent1"/>
+          </a:fillRef>
+          <a:effectRef idx="1">
+            <a:schemeClr val="accent1"/>
+          </a:effectRef>
+          <a:fontRef idx="minor">
+            <a:schemeClr val="tx1"/>
+          </a:fontRef>
+        </p:style>
+      </p:cxnSp>
+      <p:cxnSp>
+        <p:nvCxnSpPr>
+          <p:cNvPr id="16" name="Verbinder: gewinkelt 15">
+            <a:extLst>
+              <a:ext uri="{FF2B5EF4-FFF2-40B4-BE49-F238E27FC236}">
+                <a16:creationId xmlns:a16="http://schemas.microsoft.com/office/drawing/2014/main" id="{E92989F5-5050-EF6E-116C-0919382CB3AB}"/>
+              </a:ext>
+            </a:extLst>
+          </p:cNvPr>
+          <p:cNvCxnSpPr>
+            <a:cxnSpLocks/>
+            <a:stCxn id="10" idx="1"/>
+            <a:endCxn id="6" idx="0"/>
+          </p:cNvCxnSpPr>
+          <p:nvPr/>
+        </p:nvCxnSpPr>
+        <p:spPr>
+          <a:xfrm rot="10800000" flipV="1">
+            <a:off x="6285149" y="2114854"/>
+            <a:ext cx="1727857" cy="666074"/>
+          </a:xfrm>
+          <a:prstGeom prst="curvedConnector2">
+            <a:avLst/>
+          </a:prstGeom>
+          <a:ln w="15875">
+            <a:solidFill>
+              <a:schemeClr val="tx1">
+                <a:lumMod val="65000"/>
+                <a:lumOff val="35000"/>
+              </a:schemeClr>
+            </a:solidFill>
+            <a:headEnd type="triangle"/>
+            <a:tailEnd type="none"/>
+          </a:ln>
+          <a:effectLst/>
+        </p:spPr>
+        <p:style>
+          <a:lnRef idx="2">
+            <a:schemeClr val="accent1"/>
+          </a:lnRef>
+          <a:fillRef idx="0">
+            <a:schemeClr val="accent1"/>
+          </a:fillRef>
+          <a:effectRef idx="1">
+            <a:schemeClr val="accent1"/>
+          </a:effectRef>
+          <a:fontRef idx="minor">
+            <a:schemeClr val="tx1"/>
+          </a:fontRef>
+        </p:style>
+      </p:cxnSp>
     </p:spTree>
     <p:extLst>
       <p:ext uri="{BB962C8B-B14F-4D97-AF65-F5344CB8AC3E}">

</xml_diff>

<commit_message>
excluding markdown last changed lines from being commited as change
</commit_message>
<xml_diff>
--- a/doc/architecture.pptx
+++ b/doc/architecture.pptx
@@ -208,6 +208,29 @@
     </p:extLst>
   </p:cmAuthor>
 </p:cmAuthorLst>
+</file>
+
+<file path=ppt/comments/modernComment_57F_2E5579E7.xml><?xml version="1.0" encoding="utf-8"?>
+<p188:cmLst xmlns:a="http://schemas.openxmlformats.org/drawingml/2006/main" xmlns:r="http://schemas.openxmlformats.org/officeDocument/2006/relationships" xmlns:p188="http://schemas.microsoft.com/office/powerpoint/2018/8/main">
+  <p188:cm id="{55092677-D017-4272-BA05-B5AD5EB8D378}" authorId="{D189D656-8E02-B9F1-10F5-52BD840A97A1}" created="2026-09-11T07:24:50.415">
+    <ac:deMkLst xmlns:ac="http://schemas.microsoft.com/office/drawing/2013/main/command">
+      <pc:docMk xmlns:pc="http://schemas.microsoft.com/office/powerpoint/2013/main/command"/>
+      <pc:sldMk xmlns:pc="http://schemas.microsoft.com/office/powerpoint/2013/main/command" cId="777353703" sldId="1407"/>
+      <ac:spMk id="34" creationId="{5B6E46C9-56C8-F21E-1BA4-D5E4FEFC31A9}"/>
+    </ac:deMkLst>
+    <p188:txBody>
+      <a:bodyPr/>
+      <a:lstStyle/>
+      <a:p>
+        <a:r>
+          <a:rPr lang="de-DE"/>
+          <a:t>Server side OCR of image-only PDF text,
+„headless browser“</a:t>
+        </a:r>
+      </a:p>
+    </p188:txBody>
+  </p188:cm>
+</p188:cmLst>
 </file>
 
 <file path=ppt/handoutMasters/handoutMaster1.xml><?xml version="1.0" encoding="utf-8"?>
@@ -6205,7 +6228,7 @@
             </a:pPr>
             <a:r>
               <a:rPr lang="en-GB" sz="2400" i="1" dirty="0"/>
-              <a:t>~Weekly </a:t>
+              <a:t>~biweekly </a:t>
             </a:r>
             <a:r>
               <a:rPr lang="en-GB" sz="2400" dirty="0"/>
@@ -6232,7 +6255,7 @@
             </a:pPr>
             <a:r>
               <a:rPr lang="en-GB" sz="2400" dirty="0"/>
-              <a:t>Editorials towards board decisions</a:t>
+              <a:t>Editorials on council decisions</a:t>
             </a:r>
           </a:p>
           <a:p>
@@ -6242,7 +6265,7 @@
             </a:pPr>
             <a:r>
               <a:rPr lang="en-GB" sz="2400" dirty="0"/>
-              <a:t>Editorials around academic research</a:t>
+              <a:t>Editorials on academic research</a:t>
             </a:r>
           </a:p>
           <a:p>
@@ -6381,6 +6404,55 @@
             <a:endParaRPr lang="en-GB" sz="2400" noProof="0" dirty="0"/>
           </a:p>
           <a:p>
+            <a:pPr marL="792163" lvl="1" indent="-342900">
+              <a:buFont typeface="Arial" panose="020B0604020202020204" pitchFamily="34" charset="0"/>
+              <a:buChar char="•"/>
+            </a:pPr>
+            <a:r>
+              <a:rPr lang="en-GB" sz="2400" dirty="0"/>
+              <a:t>S</a:t>
+            </a:r>
+            <a:r>
+              <a:rPr lang="en-GB" sz="2400" noProof="0" dirty="0" err="1"/>
+              <a:t>ubdomain</a:t>
+            </a:r>
+            <a:r>
+              <a:rPr lang="en-GB" sz="2400" noProof="0" dirty="0"/>
+              <a:t> of ZEW Institute, hosted at ZEW Institute</a:t>
+            </a:r>
+          </a:p>
+          <a:p>
+            <a:pPr marL="792163" lvl="1" indent="-342900">
+              <a:buFont typeface="Arial" panose="020B0604020202020204" pitchFamily="34" charset="0"/>
+              <a:buChar char="•"/>
+            </a:pPr>
+            <a:r>
+              <a:rPr lang="en-GB" sz="2400" dirty="0"/>
+              <a:t>Separate webserver, hosted at ZEW institute, at “DMZ”</a:t>
+            </a:r>
+            <a:endParaRPr lang="en-GB" sz="2400" noProof="0" dirty="0"/>
+          </a:p>
+          <a:p>
+            <a:pPr marL="792163" lvl="1" indent="-342900">
+              <a:buFont typeface="Arial" panose="020B0604020202020204" pitchFamily="34" charset="0"/>
+              <a:buChar char="•"/>
+            </a:pPr>
+            <a:r>
+              <a:rPr lang="en-GB" sz="2400" dirty="0"/>
+              <a:t>ZEW corporate design – cooperation with KOM</a:t>
+            </a:r>
+          </a:p>
+          <a:p>
+            <a:pPr marL="792163" lvl="1" indent="-342900">
+              <a:buFont typeface="Arial" panose="020B0604020202020204" pitchFamily="34" charset="0"/>
+              <a:buChar char="•"/>
+            </a:pPr>
+            <a:r>
+              <a:rPr lang="en-GB" sz="2400" dirty="0"/>
+              <a:t>Illustrations via behance.net</a:t>
+            </a:r>
+          </a:p>
+          <a:p>
             <a:pPr marL="342900" indent="-342900">
               <a:lnSpc>
                 <a:spcPct val="100000"/>
@@ -6390,15 +6462,7 @@
             </a:pPr>
             <a:r>
               <a:rPr lang="en-GB" sz="2400" dirty="0"/>
-              <a:t>S</a:t>
-            </a:r>
-            <a:r>
-              <a:rPr lang="en-GB" sz="2400" noProof="0" dirty="0" err="1"/>
-              <a:t>ubdomain</a:t>
-            </a:r>
-            <a:r>
-              <a:rPr lang="en-GB" sz="2400" noProof="0" dirty="0"/>
-              <a:t> of ZEW Institute, hosted at ZEW Institute</a:t>
+              <a:t>Separate visitor statistics – no cookies</a:t>
             </a:r>
           </a:p>
           <a:p>
@@ -6411,47 +6475,7 @@
             </a:pPr>
             <a:r>
               <a:rPr lang="en-GB" sz="2400" dirty="0"/>
-              <a:t>Separate webserver, hosted at ZEW institute, at “DMZ”</a:t>
-            </a:r>
-            <a:endParaRPr lang="en-GB" sz="2400" noProof="0" dirty="0"/>
-          </a:p>
-          <a:p>
-            <a:pPr marL="342900" indent="-342900">
-              <a:lnSpc>
-                <a:spcPct val="100000"/>
-              </a:lnSpc>
-              <a:buFont typeface="Arial" panose="020B0604020202020204" pitchFamily="34" charset="0"/>
-              <a:buChar char="•"/>
-            </a:pPr>
-            <a:r>
-              <a:rPr lang="en-GB" sz="2400" dirty="0"/>
-              <a:t>ZEW corporate design – cooperation with KOM</a:t>
-            </a:r>
-          </a:p>
-          <a:p>
-            <a:pPr marL="342900" indent="-342900">
-              <a:lnSpc>
-                <a:spcPct val="100000"/>
-              </a:lnSpc>
-              <a:buFont typeface="Arial" panose="020B0604020202020204" pitchFamily="34" charset="0"/>
-              <a:buChar char="•"/>
-            </a:pPr>
-            <a:r>
-              <a:rPr lang="en-GB" sz="2400" dirty="0"/>
-              <a:t>Separate visitor statistics – no cookies</a:t>
-            </a:r>
-          </a:p>
-          <a:p>
-            <a:pPr marL="342900" indent="-342900">
-              <a:lnSpc>
-                <a:spcPct val="100000"/>
-              </a:lnSpc>
-              <a:buFont typeface="Arial" panose="020B0604020202020204" pitchFamily="34" charset="0"/>
-              <a:buChar char="•"/>
-            </a:pPr>
-            <a:r>
-              <a:rPr lang="en-GB" sz="2400" dirty="0"/>
-              <a:t>Based 100% on Open-Source software</a:t>
+              <a:t>100% Open-Source software</a:t>
             </a:r>
           </a:p>
           <a:p>
@@ -11817,6 +11841,41 @@
           </a:p>
         </p:txBody>
       </p:sp>
+      <p:sp>
+        <p:nvSpPr>
+          <p:cNvPr id="34" name="Textfeld 33">
+            <a:extLst>
+              <a:ext uri="{FF2B5EF4-FFF2-40B4-BE49-F238E27FC236}">
+                <a16:creationId xmlns:a16="http://schemas.microsoft.com/office/drawing/2014/main" id="{5B6E46C9-56C8-F21E-1BA4-D5E4FEFC31A9}"/>
+              </a:ext>
+            </a:extLst>
+          </p:cNvPr>
+          <p:cNvSpPr txBox="1"/>
+          <p:nvPr/>
+        </p:nvSpPr>
+        <p:spPr>
+          <a:xfrm>
+            <a:off x="9648497" y="4403834"/>
+            <a:ext cx="65" cy="276999"/>
+          </a:xfrm>
+          <a:prstGeom prst="rect">
+            <a:avLst/>
+          </a:prstGeom>
+          <a:noFill/>
+        </p:spPr>
+        <p:txBody>
+          <a:bodyPr wrap="none" lIns="0" tIns="0" rIns="0" bIns="0" rtlCol="0">
+            <a:spAutoFit/>
+          </a:bodyPr>
+          <a:lstStyle/>
+          <a:p>
+            <a:endParaRPr lang="de-DE" dirty="0" err="1">
+              <a:latin typeface="Arial" panose="020B0604020202020204" pitchFamily="34" charset="0"/>
+              <a:cs typeface="Arial" panose="020B0604020202020204" pitchFamily="34" charset="0"/>
+            </a:endParaRPr>
+          </a:p>
+        </p:txBody>
+      </p:sp>
     </p:spTree>
     <p:extLst>
       <p:ext uri="{BB962C8B-B14F-4D97-AF65-F5344CB8AC3E}">
@@ -11827,6 +11886,11 @@
   <p:clrMapOvr>
     <a:masterClrMapping/>
   </p:clrMapOvr>
+  <p:extLst>
+    <p:ext uri="{6950BFC3-D8DA-4A85-94F7-54DA5524770B}">
+      <p188:commentRel xmlns:p188="http://schemas.microsoft.com/office/powerpoint/2018/8/main" r:id="rId3"/>
+    </p:ext>
+  </p:extLst>
 </p:sld>
 </file>
 

</xml_diff>